<commit_message>
4-12・4-14 spec: 22pt に収まらない表を分割（4-12 S6→S6/S7、4-14 S5〜S7→S5〜S10）
Co-Authored-By: Claude Fable 5.1 <noreply@anthropic.com>
Claude-Session: https://claude.ai/code/session_01SAUkWCQGmQmBwHabYZKgkn
</commit_message>
<xml_diff>
--- a/slides/4-8_cardiac_conditions/4-8_cardiac_conditions.pptx
+++ b/slides/4-8_cardiac_conditions/4-8_cardiac_conditions.pptx
@@ -3136,7 +3136,7 @@
                 <a:gridCol w="219456"/>
                 <a:gridCol w="5552237"/>
               </a:tblGrid>
-              <a:tr h="808330">
+              <a:tr h="696773">
                 <a:tc>
                   <a:txBody>
                     <a:bodyPr/>
@@ -3166,7 +3166,7 @@
                       </a:endParaRPr>
                     </a:p>
                   </a:txBody>
-                  <a:tcPr marL="0" marR="0" marT="0" marB="138074" anchor="t">
+                  <a:tcPr marL="0" marR="0" marT="0" marB="26518" anchor="t">
                     <a:lnL w="0" cap="flat" cmpd="sng" algn="ctr">
                       <a:noFill/>
                     </a:lnL>
@@ -3234,7 +3234,7 @@
                       </a:endParaRPr>
                     </a:p>
                   </a:txBody>
-                  <a:tcPr marL="0" marR="0" marT="0" marB="138074" anchor="t">
+                  <a:tcPr marL="0" marR="0" marT="0" marB="26518" anchor="t">
                     <a:lnL w="0" cap="flat" cmpd="sng" algn="ctr">
                       <a:noFill/>
                     </a:lnL>
@@ -3250,7 +3250,7 @@
                   </a:tcPr>
                 </a:tc>
               </a:tr>
-              <a:tr h="808330">
+              <a:tr h="696773">
                 <a:tc>
                   <a:txBody>
                     <a:bodyPr/>
@@ -3280,7 +3280,7 @@
                       </a:endParaRPr>
                     </a:p>
                   </a:txBody>
-                  <a:tcPr marL="0" marR="0" marT="0" marB="138074" anchor="t">
+                  <a:tcPr marL="0" marR="0" marT="0" marB="26518" anchor="t">
                     <a:lnL w="0" cap="flat" cmpd="sng" algn="ctr">
                       <a:noFill/>
                     </a:lnL>
@@ -3348,7 +3348,7 @@
                       </a:endParaRPr>
                     </a:p>
                   </a:txBody>
-                  <a:tcPr marL="0" marR="0" marT="0" marB="138074" anchor="t">
+                  <a:tcPr marL="0" marR="0" marT="0" marB="26518" anchor="t">
                     <a:lnL w="0" cap="flat" cmpd="sng" algn="ctr">
                       <a:noFill/>
                     </a:lnL>
@@ -3364,7 +3364,7 @@
                   </a:tcPr>
                 </a:tc>
               </a:tr>
-              <a:tr h="808330">
+              <a:tr h="696773">
                 <a:tc>
                   <a:txBody>
                     <a:bodyPr/>
@@ -3394,7 +3394,7 @@
                       </a:endParaRPr>
                     </a:p>
                   </a:txBody>
-                  <a:tcPr marL="0" marR="0" marT="0" marB="138074" anchor="t">
+                  <a:tcPr marL="0" marR="0" marT="0" marB="26518" anchor="t">
                     <a:lnL w="0" cap="flat" cmpd="sng" algn="ctr">
                       <a:noFill/>
                     </a:lnL>
@@ -3462,7 +3462,7 @@
                       </a:endParaRPr>
                     </a:p>
                   </a:txBody>
-                  <a:tcPr marL="0" marR="0" marT="0" marB="138074" anchor="t">
+                  <a:tcPr marL="0" marR="0" marT="0" marB="26518" anchor="t">
                     <a:lnL w="0" cap="flat" cmpd="sng" algn="ctr">
                       <a:noFill/>
                     </a:lnL>
@@ -4266,7 +4266,7 @@
                 <a:gridCol w="237744"/>
                 <a:gridCol w="4488790"/>
               </a:tblGrid>
-              <a:tr h="498348">
+              <a:tr h="386791">
                 <a:tc>
                   <a:txBody>
                     <a:bodyPr/>
@@ -4296,7 +4296,7 @@
                       </a:endParaRPr>
                     </a:p>
                   </a:txBody>
-                  <a:tcPr marL="0" marR="0" marT="0" marB="162763" anchor="t">
+                  <a:tcPr marL="0" marR="0" marT="0" marB="51206" anchor="t">
                     <a:lnL w="0" cap="flat" cmpd="sng" algn="ctr">
                       <a:noFill/>
                     </a:lnL>
@@ -4340,7 +4340,7 @@
                       </a:endParaRPr>
                     </a:p>
                   </a:txBody>
-                  <a:tcPr marL="0" marR="0" marT="0" marB="162763" anchor="t">
+                  <a:tcPr marL="0" marR="0" marT="0" marB="51206" anchor="t">
                     <a:lnL w="0" cap="flat" cmpd="sng" algn="ctr">
                       <a:noFill/>
                     </a:lnL>
@@ -4356,7 +4356,7 @@
                   </a:tcPr>
                 </a:tc>
               </a:tr>
-              <a:tr h="498348">
+              <a:tr h="386791">
                 <a:tc>
                   <a:txBody>
                     <a:bodyPr/>
@@ -4386,7 +4386,7 @@
                       </a:endParaRPr>
                     </a:p>
                   </a:txBody>
-                  <a:tcPr marL="0" marR="0" marT="0" marB="162763" anchor="t">
+                  <a:tcPr marL="0" marR="0" marT="0" marB="51206" anchor="t">
                     <a:lnL w="0" cap="flat" cmpd="sng" algn="ctr">
                       <a:noFill/>
                     </a:lnL>
@@ -4430,7 +4430,7 @@
                       </a:endParaRPr>
                     </a:p>
                   </a:txBody>
-                  <a:tcPr marL="0" marR="0" marT="0" marB="162763" anchor="t">
+                  <a:tcPr marL="0" marR="0" marT="0" marB="51206" anchor="t">
                     <a:lnL w="0" cap="flat" cmpd="sng" algn="ctr">
                       <a:noFill/>
                     </a:lnL>
@@ -4446,7 +4446,7 @@
                   </a:tcPr>
                 </a:tc>
               </a:tr>
-              <a:tr h="833018">
+              <a:tr h="721462">
                 <a:tc>
                   <a:txBody>
                     <a:bodyPr/>
@@ -4476,7 +4476,7 @@
                       </a:endParaRPr>
                     </a:p>
                   </a:txBody>
-                  <a:tcPr marL="0" marR="0" marT="0" marB="162763" anchor="t">
+                  <a:tcPr marL="0" marR="0" marT="0" marB="51206" anchor="t">
                     <a:lnL w="0" cap="flat" cmpd="sng" algn="ctr">
                       <a:noFill/>
                     </a:lnL>
@@ -4544,7 +4544,7 @@
                       </a:endParaRPr>
                     </a:p>
                   </a:txBody>
-                  <a:tcPr marL="0" marR="0" marT="0" marB="162763" anchor="t">
+                  <a:tcPr marL="0" marR="0" marT="0" marB="51206" anchor="t">
                     <a:lnL w="0" cap="flat" cmpd="sng" algn="ctr">
                       <a:noFill/>
                     </a:lnL>
@@ -7945,7 +7945,7 @@
                 <a:ea typeface="メイリオ" pitchFamily="34" charset="-122"/>
                 <a:cs typeface="メイリオ" pitchFamily="34" charset="-120"/>
               </a:rPr>
-              <a:t>Hawn MT, et al. JAMA 2013;310:1462-1472/Thompson A, et al. Circulation</a:t>
+              <a:t>Hawn MT, et al. JAMA 2013;310:1462-1472 / Thompson A, et al.</a:t>
             </a:r>
             <a:endParaRPr lang="ja-JP" sz="1600" dirty="0"/>
           </a:p>
@@ -7962,7 +7962,7 @@
                 <a:ea typeface="メイリオ" pitchFamily="34" charset="-122"/>
                 <a:cs typeface="メイリオ" pitchFamily="34" charset="-120"/>
               </a:rPr>
-              <a:t>2024;150:e351-e442/日本循環器学会 2022 年改訂版 非心臓手術における合併心疾患ガイドライン</a:t>
+              <a:t>Circulation 2024;150:e351-e442（2024 AHA/ACC） / JCS 2022 非心臓手術ガイドライン</a:t>
             </a:r>
             <a:endParaRPr lang="ja-JP" sz="1600" dirty="0"/>
           </a:p>
@@ -9403,7 +9403,7 @@
         <p:spPr>
           <a:xfrm>
             <a:off x="502920" y="1691640"/>
-            <a:ext cx="7046366" cy="3256178"/>
+            <a:ext cx="7002475" cy="3256178"/>
           </a:xfrm>
           <a:prstGeom prst="roundRect">
             <a:avLst>
@@ -9432,14 +9432,14 @@
         </p:nvGraphicFramePr>
         <p:xfrm>
           <a:off x="594360" y="1773936"/>
-          <a:ext cx="6863486" cy="914400"/>
+          <a:ext cx="6819595" cy="914400"/>
         </p:xfrm>
         <a:graphic>
           <a:graphicData uri="http://schemas.openxmlformats.org/drawingml/2006/table">
             <a:tbl>
               <a:tblPr/>
               <a:tblGrid>
-                <a:gridCol w="6863486"/>
+                <a:gridCol w="6819595"/>
               </a:tblGrid>
               <a:tr h="365760">
                 <a:tc>
@@ -9507,7 +9507,7 @@
         </p:nvGraphicFramePr>
         <p:xfrm>
           <a:off x="594360" y="2157984"/>
-          <a:ext cx="6863486" cy="914400"/>
+          <a:ext cx="6819595" cy="914400"/>
         </p:xfrm>
         <a:graphic>
           <a:graphicData uri="http://schemas.openxmlformats.org/drawingml/2006/table">
@@ -9515,9 +9515,9 @@
               <a:tblPr/>
               <a:tblGrid>
                 <a:gridCol w="219456"/>
-                <a:gridCol w="6644030"/>
+                <a:gridCol w="6600139"/>
               </a:tblGrid>
-              <a:tr h="354787">
+              <a:tr h="335585">
                 <a:tc>
                   <a:txBody>
                     <a:bodyPr/>
@@ -9547,7 +9547,7 @@
                       </a:endParaRPr>
                     </a:p>
                   </a:txBody>
-                  <a:tcPr marL="0" marR="0" marT="0" marB="19202" anchor="t">
+                  <a:tcPr marL="0" marR="0" marT="0" marB="0" anchor="t">
                     <a:lnL w="0" cap="flat" cmpd="sng" algn="ctr">
                       <a:noFill/>
                     </a:lnL>
@@ -9591,7 +9591,7 @@
                       </a:endParaRPr>
                     </a:p>
                   </a:txBody>
-                  <a:tcPr marL="0" marR="0" marT="0" marB="19202" anchor="t">
+                  <a:tcPr marL="0" marR="0" marT="0" marB="0" anchor="t">
                     <a:lnL w="0" cap="flat" cmpd="sng" algn="ctr">
                       <a:noFill/>
                     </a:lnL>
@@ -9607,7 +9607,7 @@
                   </a:tcPr>
                 </a:tc>
               </a:tr>
-              <a:tr h="689458">
+              <a:tr h="670255">
                 <a:tc>
                   <a:txBody>
                     <a:bodyPr/>
@@ -9637,7 +9637,7 @@
                       </a:endParaRPr>
                     </a:p>
                   </a:txBody>
-                  <a:tcPr marL="0" marR="0" marT="0" marB="19202" anchor="t">
+                  <a:tcPr marL="0" marR="0" marT="0" marB="0" anchor="t">
                     <a:lnL w="0" cap="flat" cmpd="sng" algn="ctr">
                       <a:noFill/>
                     </a:lnL>
@@ -9705,7 +9705,7 @@
                       </a:endParaRPr>
                     </a:p>
                   </a:txBody>
-                  <a:tcPr marL="0" marR="0" marT="0" marB="19202" anchor="t">
+                  <a:tcPr marL="0" marR="0" marT="0" marB="0" anchor="t">
                     <a:lnL w="0" cap="flat" cmpd="sng" algn="ctr">
                       <a:noFill/>
                     </a:lnL>
@@ -9721,7 +9721,7 @@
                   </a:tcPr>
                 </a:tc>
               </a:tr>
-              <a:tr h="354787">
+              <a:tr h="335585">
                 <a:tc>
                   <a:txBody>
                     <a:bodyPr/>
@@ -9751,7 +9751,7 @@
                       </a:endParaRPr>
                     </a:p>
                   </a:txBody>
-                  <a:tcPr marL="0" marR="0" marT="0" marB="19202" anchor="t">
+                  <a:tcPr marL="0" marR="0" marT="0" marB="0" anchor="t">
                     <a:lnL w="0" cap="flat" cmpd="sng" algn="ctr">
                       <a:noFill/>
                     </a:lnL>
@@ -9795,7 +9795,7 @@
                       </a:endParaRPr>
                     </a:p>
                   </a:txBody>
-                  <a:tcPr marL="0" marR="0" marT="0" marB="19202" anchor="t">
+                  <a:tcPr marL="0" marR="0" marT="0" marB="0" anchor="t">
                     <a:lnL w="0" cap="flat" cmpd="sng" algn="ctr">
                       <a:noFill/>
                     </a:lnL>
@@ -9811,7 +9811,7 @@
                   </a:tcPr>
                 </a:tc>
               </a:tr>
-              <a:tr h="689458">
+              <a:tr h="670255">
                 <a:tc>
                   <a:txBody>
                     <a:bodyPr/>
@@ -9841,7 +9841,7 @@
                       </a:endParaRPr>
                     </a:p>
                   </a:txBody>
-                  <a:tcPr marL="0" marR="0" marT="0" marB="19202" anchor="t">
+                  <a:tcPr marL="0" marR="0" marT="0" marB="0" anchor="t">
                     <a:lnL w="0" cap="flat" cmpd="sng" algn="ctr">
                       <a:noFill/>
                     </a:lnL>
@@ -9909,7 +9909,7 @@
                       </a:endParaRPr>
                     </a:p>
                   </a:txBody>
-                  <a:tcPr marL="0" marR="0" marT="0" marB="19202" anchor="t">
+                  <a:tcPr marL="0" marR="0" marT="0" marB="0" anchor="t">
                     <a:lnL w="0" cap="flat" cmpd="sng" algn="ctr">
                       <a:noFill/>
                     </a:lnL>
@@ -10051,8 +10051,8 @@
         </p:nvSpPr>
         <p:spPr>
           <a:xfrm>
-            <a:off x="7768742" y="1691640"/>
-            <a:ext cx="3917290" cy="3256178"/>
+            <a:off x="7724851" y="1691640"/>
+            <a:ext cx="3961181" cy="3256178"/>
           </a:xfrm>
           <a:prstGeom prst="roundRect">
             <a:avLst>
@@ -10080,15 +10080,15 @@
           </p:nvPr>
         </p:nvGraphicFramePr>
         <p:xfrm>
-          <a:off x="7860182" y="1773936"/>
-          <a:ext cx="3734410" cy="914400"/>
+          <a:off x="7816291" y="1773936"/>
+          <a:ext cx="3778301" cy="914400"/>
         </p:xfrm>
         <a:graphic>
           <a:graphicData uri="http://schemas.openxmlformats.org/drawingml/2006/table">
             <a:tbl>
               <a:tblPr/>
               <a:tblGrid>
-                <a:gridCol w="3734410"/>
+                <a:gridCol w="3778301"/>
               </a:tblGrid>
               <a:tr h="365760">
                 <a:tc>
@@ -10105,7 +10105,7 @@
                       <a:r>
                         <a:rPr lang="ja-JP" altLang="en-US" sz="2400" b="1" dirty="0">
                           <a:solidFill>
-                            <a:srgbClr val="D55E00"/>
+                            <a:srgbClr val="0072B2"/>
                           </a:solidFill>
                           <a:latin typeface="メイリオ" pitchFamily="34" charset="0"/>
                           <a:ea typeface="メイリオ" pitchFamily="34" charset="-122"/>
@@ -10155,8 +10155,8 @@
           </p:nvPr>
         </p:nvGraphicFramePr>
         <p:xfrm>
-          <a:off x="7860182" y="2157984"/>
-          <a:ext cx="3734410" cy="914400"/>
+          <a:off x="7816291" y="2157984"/>
+          <a:ext cx="3778301" cy="914400"/>
         </p:xfrm>
         <a:graphic>
           <a:graphicData uri="http://schemas.openxmlformats.org/drawingml/2006/table">
@@ -10164,9 +10164,9 @@
               <a:tblPr/>
               <a:tblGrid>
                 <a:gridCol w="219456"/>
-                <a:gridCol w="3514954"/>
+                <a:gridCol w="3558845"/>
               </a:tblGrid>
-              <a:tr h="696773">
+              <a:tr h="670255">
                 <a:tc>
                   <a:txBody>
                     <a:bodyPr/>
@@ -10196,7 +10196,7 @@
                       </a:endParaRPr>
                     </a:p>
                   </a:txBody>
-                  <a:tcPr marL="0" marR="0" marT="0" marB="26518" anchor="t">
+                  <a:tcPr marL="0" marR="0" marT="0" marB="0" anchor="t">
                     <a:lnL w="0" cap="flat" cmpd="sng" algn="ctr">
                       <a:noFill/>
                     </a:lnL>
@@ -10264,7 +10264,7 @@
                       </a:endParaRPr>
                     </a:p>
                   </a:txBody>
-                  <a:tcPr marL="0" marR="0" marT="0" marB="26518" anchor="t">
+                  <a:tcPr marL="0" marR="0" marT="0" marB="0" anchor="t">
                     <a:lnL w="0" cap="flat" cmpd="sng" algn="ctr">
                       <a:noFill/>
                     </a:lnL>
@@ -10280,7 +10280,7 @@
                   </a:tcPr>
                 </a:tc>
               </a:tr>
-              <a:tr h="1032358">
+              <a:tr h="1005840">
                 <a:tc>
                   <a:txBody>
                     <a:bodyPr/>
@@ -10310,7 +10310,7 @@
                       </a:endParaRPr>
                     </a:p>
                   </a:txBody>
-                  <a:tcPr marL="0" marR="0" marT="0" marB="26518" anchor="t">
+                  <a:tcPr marL="0" marR="0" marT="0" marB="0" anchor="t">
                     <a:lnL w="0" cap="flat" cmpd="sng" algn="ctr">
                       <a:noFill/>
                     </a:lnL>
@@ -10402,7 +10402,7 @@
                       </a:endParaRPr>
                     </a:p>
                   </a:txBody>
-                  <a:tcPr marL="0" marR="0" marT="0" marB="26518" anchor="t">
+                  <a:tcPr marL="0" marR="0" marT="0" marB="0" anchor="t">
                     <a:lnL w="0" cap="flat" cmpd="sng" algn="ctr">
                       <a:noFill/>
                     </a:lnL>
@@ -10418,7 +10418,7 @@
                   </a:tcPr>
                 </a:tc>
               </a:tr>
-              <a:tr h="362102">
+              <a:tr h="335585">
                 <a:tc>
                   <a:txBody>
                     <a:bodyPr/>
@@ -10448,7 +10448,7 @@
                       </a:endParaRPr>
                     </a:p>
                   </a:txBody>
-                  <a:tcPr marL="0" marR="0" marT="0" marB="26518" anchor="t">
+                  <a:tcPr marL="0" marR="0" marT="0" marB="0" anchor="t">
                     <a:lnL w="0" cap="flat" cmpd="sng" algn="ctr">
                       <a:noFill/>
                     </a:lnL>
@@ -10492,7 +10492,7 @@
                       </a:endParaRPr>
                     </a:p>
                   </a:txBody>
-                  <a:tcPr marL="0" marR="0" marT="0" marB="26518" anchor="t">
+                  <a:tcPr marL="0" marR="0" marT="0" marB="0" anchor="t">
                     <a:lnL w="0" cap="flat" cmpd="sng" algn="ctr">
                       <a:noFill/>
                     </a:lnL>
@@ -11219,164 +11219,517 @@
           </a:p>
         </p:txBody>
       </p:sp>
+      <p:graphicFrame>
+        <p:nvGraphicFramePr>
+          <p:cNvPr id="11" name="Table 0"/>
+          <p:cNvGraphicFramePr>
+            <a:graphicFrameLocks noGrp="1"/>
+          </p:cNvGraphicFramePr>
+          <p:nvPr>
+            <p:extLst>
+              <p:ext uri="{D42A27DB-BD31-4B8C-83A1-F6EECF244321}">
+                <p14:modId xmlns:p14="http://schemas.microsoft.com/office/powerpoint/2010/main" val="1579011935"/>
+              </p:ext>
+            </p:extLst>
+          </p:nvPr>
+        </p:nvGraphicFramePr>
+        <p:xfrm>
+          <a:off x="502920" y="1691640"/>
+          <a:ext cx="11183112" cy="914400"/>
+        </p:xfrm>
+        <a:graphic>
+          <a:graphicData uri="http://schemas.openxmlformats.org/drawingml/2006/table">
+            <a:tbl>
+              <a:tblPr/>
+              <a:tblGrid>
+                <a:gridCol w="355702"/>
+                <a:gridCol w="10827410"/>
+              </a:tblGrid>
+              <a:tr h="642823">
+                <a:tc>
+                  <a:txBody>
+                    <a:bodyPr/>
+                    <a:lstStyle/>
+                    <a:p>
+                      <a:pPr algn="l" indent="0" marL="0">
+                        <a:lnSpc>
+                          <a:spcPts val="2880"/>
+                        </a:lnSpc>
+                        <a:buNone/>
+                      </a:pPr>
+                      <a:r>
+                        <a:rPr lang="ja-JP" altLang="en-US" sz="2400" dirty="0">
+                          <a:solidFill>
+                            <a:srgbClr val="262626"/>
+                          </a:solidFill>
+                          <a:latin typeface="メイリオ" pitchFamily="34" charset="0"/>
+                          <a:ea typeface="メイリオ" pitchFamily="34" charset="-122"/>
+                          <a:cs typeface="メイリオ" pitchFamily="34" charset="-120"/>
+                        </a:rPr>
+                        <a:t>•</a:t>
+                      </a:r>
+                      <a:endParaRPr lang="en-US" sz="2400" dirty="0">
+                        <a:latin typeface="メイリオ" charset="0"/>
+                        <a:ea typeface="メイリオ" charset="0"/>
+                        <a:cs typeface="メイリオ" charset="0"/>
+                      </a:endParaRPr>
+                    </a:p>
+                  </a:txBody>
+                  <a:tcPr marL="0" marR="0" marT="0" marB="277063" anchor="t">
+                    <a:lnL w="0" cap="flat" cmpd="sng" algn="ctr">
+                      <a:noFill/>
+                    </a:lnL>
+                    <a:lnR w="0" cap="flat" cmpd="sng" algn="ctr">
+                      <a:noFill/>
+                    </a:lnR>
+                    <a:lnT w="0" cap="flat" cmpd="sng" algn="ctr">
+                      <a:noFill/>
+                    </a:lnT>
+                    <a:lnB w="0" cap="flat" cmpd="sng" algn="ctr">
+                      <a:noFill/>
+                    </a:lnB>
+                  </a:tcPr>
+                </a:tc>
+                <a:tc>
+                  <a:txBody>
+                    <a:bodyPr/>
+                    <a:lstStyle/>
+                    <a:p>
+                      <a:pPr algn="l" indent="0" marL="0">
+                        <a:lnSpc>
+                          <a:spcPts val="2880"/>
+                        </a:lnSpc>
+                        <a:buNone/>
+                      </a:pPr>
+                      <a:r>
+                        <a:rPr lang="ja-JP" altLang="en-US" sz="2400" dirty="0">
+                          <a:solidFill>
+                            <a:srgbClr val="262626"/>
+                          </a:solidFill>
+                          <a:latin typeface="メイリオ" pitchFamily="34" charset="0"/>
+                          <a:ea typeface="メイリオ" pitchFamily="34" charset="-122"/>
+                          <a:cs typeface="メイリオ" pitchFamily="34" charset="-120"/>
+                        </a:rPr>
+                        <a:t>定義：安静時の平均肺動脈圧 20 mmHg 超（2022 ESC/ERS）</a:t>
+                      </a:r>
+                      <a:endParaRPr lang="en-US" sz="2400" dirty="0">
+                        <a:latin typeface="メイリオ" charset="0"/>
+                        <a:ea typeface="メイリオ" charset="0"/>
+                        <a:cs typeface="メイリオ" charset="0"/>
+                      </a:endParaRPr>
+                    </a:p>
+                  </a:txBody>
+                  <a:tcPr marL="0" marR="0" marT="0" marB="277063" anchor="t">
+                    <a:lnL w="0" cap="flat" cmpd="sng" algn="ctr">
+                      <a:noFill/>
+                    </a:lnL>
+                    <a:lnR w="0" cap="flat" cmpd="sng" algn="ctr">
+                      <a:noFill/>
+                    </a:lnR>
+                    <a:lnT w="0" cap="flat" cmpd="sng" algn="ctr">
+                      <a:noFill/>
+                    </a:lnT>
+                    <a:lnB w="0" cap="flat" cmpd="sng" algn="ctr">
+                      <a:noFill/>
+                    </a:lnB>
+                  </a:tcPr>
+                </a:tc>
+              </a:tr>
+              <a:tr h="642823">
+                <a:tc>
+                  <a:txBody>
+                    <a:bodyPr/>
+                    <a:lstStyle/>
+                    <a:p>
+                      <a:pPr algn="l" indent="0" marL="0">
+                        <a:lnSpc>
+                          <a:spcPts val="2880"/>
+                        </a:lnSpc>
+                        <a:buNone/>
+                      </a:pPr>
+                      <a:r>
+                        <a:rPr lang="ja-JP" altLang="en-US" sz="2400" dirty="0">
+                          <a:solidFill>
+                            <a:srgbClr val="262626"/>
+                          </a:solidFill>
+                          <a:latin typeface="メイリオ" pitchFamily="34" charset="0"/>
+                          <a:ea typeface="メイリオ" pitchFamily="34" charset="-122"/>
+                          <a:cs typeface="メイリオ" pitchFamily="34" charset="-120"/>
+                        </a:rPr>
+                        <a:t>•</a:t>
+                      </a:r>
+                      <a:endParaRPr lang="en-US" sz="2400" dirty="0">
+                        <a:latin typeface="メイリオ" charset="0"/>
+                        <a:ea typeface="メイリオ" charset="0"/>
+                        <a:cs typeface="メイリオ" charset="0"/>
+                      </a:endParaRPr>
+                    </a:p>
+                  </a:txBody>
+                  <a:tcPr marL="0" marR="0" marT="0" marB="277063" anchor="t">
+                    <a:lnL w="0" cap="flat" cmpd="sng" algn="ctr">
+                      <a:noFill/>
+                    </a:lnL>
+                    <a:lnR w="0" cap="flat" cmpd="sng" algn="ctr">
+                      <a:noFill/>
+                    </a:lnR>
+                    <a:lnT w="0" cap="flat" cmpd="sng" algn="ctr">
+                      <a:noFill/>
+                    </a:lnT>
+                    <a:lnB w="0" cap="flat" cmpd="sng" algn="ctr">
+                      <a:noFill/>
+                    </a:lnB>
+                  </a:tcPr>
+                </a:tc>
+                <a:tc>
+                  <a:txBody>
+                    <a:bodyPr/>
+                    <a:lstStyle/>
+                    <a:p>
+                      <a:pPr algn="l" indent="0" marL="0">
+                        <a:lnSpc>
+                          <a:spcPts val="2880"/>
+                        </a:lnSpc>
+                        <a:buNone/>
+                      </a:pPr>
+                      <a:r>
+                        <a:rPr lang="ja-JP" altLang="en-US" sz="2400" dirty="0">
+                          <a:solidFill>
+                            <a:srgbClr val="262626"/>
+                          </a:solidFill>
+                          <a:latin typeface="メイリオ" pitchFamily="34" charset="0"/>
+                          <a:ea typeface="メイリオ" pitchFamily="34" charset="-122"/>
+                          <a:cs typeface="メイリオ" pitchFamily="34" charset="-120"/>
+                        </a:rPr>
+                        <a:t>非心臓手術の早期死亡 7%。肺動脈性肺高血圧の</a:t>
+                      </a:r>
+                      <a:r>
+                        <a:rPr lang="ja-JP" altLang="en-US" sz="2400" b="1" dirty="0">
+                          <a:solidFill>
+                            <a:srgbClr val="D55E00"/>
+                          </a:solidFill>
+                          <a:latin typeface="メイリオ" pitchFamily="34" charset="0"/>
+                          <a:ea typeface="メイリオ" pitchFamily="34" charset="-122"/>
+                          <a:cs typeface="メイリオ" pitchFamily="34" charset="-120"/>
+                        </a:rPr>
+                        <a:t>緊急手術は 15%</a:t>
+                      </a:r>
+                      <a:endParaRPr lang="en-US" sz="2400" dirty="0">
+                        <a:latin typeface="メイリオ" charset="0"/>
+                        <a:ea typeface="メイリオ" charset="0"/>
+                        <a:cs typeface="メイリオ" charset="0"/>
+                      </a:endParaRPr>
+                    </a:p>
+                  </a:txBody>
+                  <a:tcPr marL="0" marR="0" marT="0" marB="277063" anchor="t">
+                    <a:lnL w="0" cap="flat" cmpd="sng" algn="ctr">
+                      <a:noFill/>
+                    </a:lnL>
+                    <a:lnR w="0" cap="flat" cmpd="sng" algn="ctr">
+                      <a:noFill/>
+                    </a:lnR>
+                    <a:lnT w="0" cap="flat" cmpd="sng" algn="ctr">
+                      <a:noFill/>
+                    </a:lnT>
+                    <a:lnB w="0" cap="flat" cmpd="sng" algn="ctr">
+                      <a:noFill/>
+                    </a:lnB>
+                  </a:tcPr>
+                </a:tc>
+              </a:tr>
+              <a:tr h="642823">
+                <a:tc>
+                  <a:txBody>
+                    <a:bodyPr/>
+                    <a:lstStyle/>
+                    <a:p>
+                      <a:pPr algn="l" indent="0" marL="0">
+                        <a:lnSpc>
+                          <a:spcPts val="2880"/>
+                        </a:lnSpc>
+                        <a:buNone/>
+                      </a:pPr>
+                      <a:r>
+                        <a:rPr lang="ja-JP" altLang="en-US" sz="2400" dirty="0">
+                          <a:solidFill>
+                            <a:srgbClr val="262626"/>
+                          </a:solidFill>
+                          <a:latin typeface="メイリオ" pitchFamily="34" charset="0"/>
+                          <a:ea typeface="メイリオ" pitchFamily="34" charset="-122"/>
+                          <a:cs typeface="メイリオ" pitchFamily="34" charset="-120"/>
+                        </a:rPr>
+                        <a:t>•</a:t>
+                      </a:r>
+                      <a:endParaRPr lang="en-US" sz="2400" dirty="0">
+                        <a:latin typeface="メイリオ" charset="0"/>
+                        <a:ea typeface="メイリオ" charset="0"/>
+                        <a:cs typeface="メイリオ" charset="0"/>
+                      </a:endParaRPr>
+                    </a:p>
+                  </a:txBody>
+                  <a:tcPr marL="0" marR="0" marT="0" marB="277063" anchor="t">
+                    <a:lnL w="0" cap="flat" cmpd="sng" algn="ctr">
+                      <a:noFill/>
+                    </a:lnL>
+                    <a:lnR w="0" cap="flat" cmpd="sng" algn="ctr">
+                      <a:noFill/>
+                    </a:lnR>
+                    <a:lnT w="0" cap="flat" cmpd="sng" algn="ctr">
+                      <a:noFill/>
+                    </a:lnT>
+                    <a:lnB w="0" cap="flat" cmpd="sng" algn="ctr">
+                      <a:noFill/>
+                    </a:lnB>
+                  </a:tcPr>
+                </a:tc>
+                <a:tc>
+                  <a:txBody>
+                    <a:bodyPr/>
+                    <a:lstStyle/>
+                    <a:p>
+                      <a:pPr algn="l" indent="0" marL="0">
+                        <a:lnSpc>
+                          <a:spcPts val="2880"/>
+                        </a:lnSpc>
+                        <a:buNone/>
+                      </a:pPr>
+                      <a:r>
+                        <a:rPr lang="ja-JP" altLang="en-US" sz="2400" dirty="0">
+                          <a:solidFill>
+                            <a:srgbClr val="262626"/>
+                          </a:solidFill>
+                          <a:latin typeface="メイリオ" pitchFamily="34" charset="0"/>
+                          <a:ea typeface="メイリオ" pitchFamily="34" charset="-122"/>
+                          <a:cs typeface="メイリオ" pitchFamily="34" charset="-120"/>
+                        </a:rPr>
+                        <a:t>合併症を増やす：右房圧上昇、6 分間歩行 399 m 未満、昇圧薬、緊急</a:t>
+                      </a:r>
+                      <a:endParaRPr lang="en-US" sz="2400" dirty="0">
+                        <a:latin typeface="メイリオ" charset="0"/>
+                        <a:ea typeface="メイリオ" charset="0"/>
+                        <a:cs typeface="メイリオ" charset="0"/>
+                      </a:endParaRPr>
+                    </a:p>
+                  </a:txBody>
+                  <a:tcPr marL="0" marR="0" marT="0" marB="277063" anchor="t">
+                    <a:lnL w="0" cap="flat" cmpd="sng" algn="ctr">
+                      <a:noFill/>
+                    </a:lnL>
+                    <a:lnR w="0" cap="flat" cmpd="sng" algn="ctr">
+                      <a:noFill/>
+                    </a:lnR>
+                    <a:lnT w="0" cap="flat" cmpd="sng" algn="ctr">
+                      <a:noFill/>
+                    </a:lnT>
+                    <a:lnB w="0" cap="flat" cmpd="sng" algn="ctr">
+                      <a:noFill/>
+                    </a:lnB>
+                  </a:tcPr>
+                </a:tc>
+              </a:tr>
+              <a:tr h="642823">
+                <a:tc>
+                  <a:txBody>
+                    <a:bodyPr/>
+                    <a:lstStyle/>
+                    <a:p>
+                      <a:pPr algn="l" indent="0" marL="0">
+                        <a:lnSpc>
+                          <a:spcPts val="2880"/>
+                        </a:lnSpc>
+                        <a:buNone/>
+                      </a:pPr>
+                      <a:r>
+                        <a:rPr lang="ja-JP" altLang="en-US" sz="2400" dirty="0">
+                          <a:solidFill>
+                            <a:srgbClr val="262626"/>
+                          </a:solidFill>
+                          <a:latin typeface="メイリオ" pitchFamily="34" charset="0"/>
+                          <a:ea typeface="メイリオ" pitchFamily="34" charset="-122"/>
+                          <a:cs typeface="メイリオ" pitchFamily="34" charset="-120"/>
+                        </a:rPr>
+                        <a:t>•</a:t>
+                      </a:r>
+                      <a:endParaRPr lang="en-US" sz="2400" dirty="0">
+                        <a:latin typeface="メイリオ" charset="0"/>
+                        <a:ea typeface="メイリオ" charset="0"/>
+                        <a:cs typeface="メイリオ" charset="0"/>
+                      </a:endParaRPr>
+                    </a:p>
+                  </a:txBody>
+                  <a:tcPr marL="0" marR="0" marT="0" marB="277063" anchor="t">
+                    <a:lnL w="0" cap="flat" cmpd="sng" algn="ctr">
+                      <a:noFill/>
+                    </a:lnL>
+                    <a:lnR w="0" cap="flat" cmpd="sng" algn="ctr">
+                      <a:noFill/>
+                    </a:lnR>
+                    <a:lnT w="0" cap="flat" cmpd="sng" algn="ctr">
+                      <a:noFill/>
+                    </a:lnT>
+                    <a:lnB w="0" cap="flat" cmpd="sng" algn="ctr">
+                      <a:noFill/>
+                    </a:lnB>
+                  </a:tcPr>
+                </a:tc>
+                <a:tc>
+                  <a:txBody>
+                    <a:bodyPr/>
+                    <a:lstStyle/>
+                    <a:p>
+                      <a:pPr algn="l" indent="0" marL="0">
+                        <a:lnSpc>
+                          <a:spcPts val="2880"/>
+                        </a:lnSpc>
+                        <a:buNone/>
+                      </a:pPr>
+                      <a:r>
+                        <a:rPr lang="ja-JP" altLang="en-US" sz="2400" dirty="0">
+                          <a:solidFill>
+                            <a:srgbClr val="262626"/>
+                          </a:solidFill>
+                          <a:latin typeface="メイリオ" pitchFamily="34" charset="0"/>
+                          <a:ea typeface="メイリオ" pitchFamily="34" charset="-122"/>
+                          <a:cs typeface="メイリオ" pitchFamily="34" charset="-120"/>
+                        </a:rPr>
+                        <a:t>肺高血圧の治療薬は続ける（I）。心エコー・右心カテで層別化</a:t>
+                      </a:r>
+                      <a:endParaRPr lang="en-US" sz="2400" dirty="0">
+                        <a:latin typeface="メイリオ" charset="0"/>
+                        <a:ea typeface="メイリオ" charset="0"/>
+                        <a:cs typeface="メイリオ" charset="0"/>
+                      </a:endParaRPr>
+                    </a:p>
+                  </a:txBody>
+                  <a:tcPr marL="0" marR="0" marT="0" marB="277063" anchor="t">
+                    <a:lnL w="0" cap="flat" cmpd="sng" algn="ctr">
+                      <a:noFill/>
+                    </a:lnL>
+                    <a:lnR w="0" cap="flat" cmpd="sng" algn="ctr">
+                      <a:noFill/>
+                    </a:lnR>
+                    <a:lnT w="0" cap="flat" cmpd="sng" algn="ctr">
+                      <a:noFill/>
+                    </a:lnT>
+                    <a:lnB w="0" cap="flat" cmpd="sng" algn="ctr">
+                      <a:noFill/>
+                    </a:lnB>
+                  </a:tcPr>
+                </a:tc>
+              </a:tr>
+              <a:tr h="365760">
+                <a:tc>
+                  <a:txBody>
+                    <a:bodyPr/>
+                    <a:lstStyle/>
+                    <a:p>
+                      <a:pPr algn="l" indent="0" marL="0">
+                        <a:lnSpc>
+                          <a:spcPts val="2880"/>
+                        </a:lnSpc>
+                        <a:buNone/>
+                      </a:pPr>
+                      <a:r>
+                        <a:rPr lang="ja-JP" altLang="en-US" sz="2400" dirty="0">
+                          <a:solidFill>
+                            <a:srgbClr val="262626"/>
+                          </a:solidFill>
+                          <a:latin typeface="メイリオ" pitchFamily="34" charset="0"/>
+                          <a:ea typeface="メイリオ" pitchFamily="34" charset="-122"/>
+                          <a:cs typeface="メイリオ" pitchFamily="34" charset="-120"/>
+                        </a:rPr>
+                        <a:t>•</a:t>
+                      </a:r>
+                      <a:endParaRPr lang="en-US" sz="2400" dirty="0">
+                        <a:latin typeface="メイリオ" charset="0"/>
+                        <a:ea typeface="メイリオ" charset="0"/>
+                        <a:cs typeface="メイリオ" charset="0"/>
+                      </a:endParaRPr>
+                    </a:p>
+                  </a:txBody>
+                  <a:tcPr marL="0" marR="0" marT="0" marB="0" anchor="t">
+                    <a:lnL w="0" cap="flat" cmpd="sng" algn="ctr">
+                      <a:noFill/>
+                    </a:lnL>
+                    <a:lnR w="0" cap="flat" cmpd="sng" algn="ctr">
+                      <a:noFill/>
+                    </a:lnR>
+                    <a:lnT w="0" cap="flat" cmpd="sng" algn="ctr">
+                      <a:noFill/>
+                    </a:lnT>
+                    <a:lnB w="0" cap="flat" cmpd="sng" algn="ctr">
+                      <a:noFill/>
+                    </a:lnB>
+                  </a:tcPr>
+                </a:tc>
+                <a:tc>
+                  <a:txBody>
+                    <a:bodyPr/>
+                    <a:lstStyle/>
+                    <a:p>
+                      <a:pPr algn="l" indent="0" marL="0">
+                        <a:lnSpc>
+                          <a:spcPts val="2880"/>
+                        </a:lnSpc>
+                        <a:buNone/>
+                      </a:pPr>
+                      <a:r>
+                        <a:rPr lang="ja-JP" altLang="en-US" sz="2400" b="1" dirty="0">
+                          <a:solidFill>
+                            <a:srgbClr val="D55E00"/>
+                          </a:solidFill>
+                          <a:latin typeface="メイリオ" pitchFamily="34" charset="0"/>
+                          <a:ea typeface="メイリオ" pitchFamily="34" charset="-122"/>
+                          <a:cs typeface="メイリオ" pitchFamily="34" charset="-120"/>
+                        </a:rPr>
+                        <a:t>避ける：</a:t>
+                      </a:r>
+                      <a:r>
+                        <a:rPr lang="ja-JP" altLang="en-US" sz="2400" dirty="0">
+                          <a:solidFill>
+                            <a:srgbClr val="262626"/>
+                          </a:solidFill>
+                          <a:latin typeface="メイリオ" pitchFamily="34" charset="0"/>
+                          <a:ea typeface="メイリオ" pitchFamily="34" charset="-122"/>
+                          <a:cs typeface="メイリオ" pitchFamily="34" charset="-120"/>
+                        </a:rPr>
+                        <a:t>低酸素、高 CO2、アシドーシス、低体温、低血圧</a:t>
+                      </a:r>
+                      <a:endParaRPr lang="en-US" sz="2400" dirty="0">
+                        <a:latin typeface="メイリオ" charset="0"/>
+                        <a:ea typeface="メイリオ" charset="0"/>
+                        <a:cs typeface="メイリオ" charset="0"/>
+                      </a:endParaRPr>
+                    </a:p>
+                  </a:txBody>
+                  <a:tcPr marL="0" marR="0" marT="0" marB="0" anchor="t">
+                    <a:lnL w="0" cap="flat" cmpd="sng" algn="ctr">
+                      <a:noFill/>
+                    </a:lnL>
+                    <a:lnR w="0" cap="flat" cmpd="sng" algn="ctr">
+                      <a:noFill/>
+                    </a:lnR>
+                    <a:lnT w="0" cap="flat" cmpd="sng" algn="ctr">
+                      <a:noFill/>
+                    </a:lnT>
+                    <a:lnB w="0" cap="flat" cmpd="sng" algn="ctr">
+                      <a:noFill/>
+                    </a:lnB>
+                  </a:tcPr>
+                </a:tc>
+              </a:tr>
+            </a:tbl>
+          </a:graphicData>
+        </a:graphic>
+      </p:graphicFrame>
       <p:sp>
         <p:nvSpPr>
-          <p:cNvPr id="11" name="Text 9"/>
-          <p:cNvSpPr txBox="1"/>
-          <p:nvPr/>
-        </p:nvSpPr>
-        <p:spPr>
-          <a:xfrm>
-            <a:off x="502920" y="1737360"/>
-            <a:ext cx="11155680" cy="2898648"/>
-          </a:xfrm>
-          <a:prstGeom prst="rect">
-            <a:avLst/>
-          </a:prstGeom>
-          <a:noFill/>
-          <a:ln/>
-        </p:spPr>
-        <p:txBody>
-          <a:bodyPr wrap="square" lIns="0" tIns="0" rIns="0" bIns="0" rtlCol="0" anchor="t"/>
-          <a:lstStyle/>
-          <a:p>
-            <a:pPr algn="l" marL="355600" indent="-355600">
-              <a:spcAft>
-                <a:spcPts val="1200"/>
-              </a:spcAft>
-              <a:buSzPct val="100000"/>
-              <a:buChar char="•"/>
-            </a:pPr>
-            <a:r>
-              <a:rPr lang="ja-JP" altLang="en-US" sz="2400" dirty="0">
-                <a:solidFill>
-                  <a:srgbClr val="262626"/>
-                </a:solidFill>
-                <a:latin typeface="メイリオ" pitchFamily="34" charset="0"/>
-                <a:ea typeface="メイリオ" pitchFamily="34" charset="-122"/>
-                <a:cs typeface="メイリオ" pitchFamily="34" charset="-120"/>
-              </a:rPr>
-              <a:t>定義：安静時の平均肺動脈圧 20 mmHg 超（2022 ESC/ERS）</a:t>
-            </a:r>
-            <a:endParaRPr lang="ja-JP" sz="2400" dirty="0"/>
-          </a:p>
-          <a:p>
-            <a:pPr algn="l" marL="355600" indent="-355600">
-              <a:spcAft>
-                <a:spcPts val="1200"/>
-              </a:spcAft>
-              <a:buSzPct val="100000"/>
-              <a:buChar char="•"/>
-            </a:pPr>
-            <a:r>
-              <a:rPr lang="ja-JP" altLang="en-US" sz="2400" dirty="0">
-                <a:solidFill>
-                  <a:srgbClr val="262626"/>
-                </a:solidFill>
-                <a:latin typeface="メイリオ" pitchFamily="34" charset="0"/>
-                <a:ea typeface="メイリオ" pitchFamily="34" charset="-122"/>
-                <a:cs typeface="メイリオ" pitchFamily="34" charset="-120"/>
-              </a:rPr>
-              <a:t>非心臓手術の早期死亡 7%。肺動脈性肺高血圧の</a:t>
-            </a:r>
-            <a:r>
-              <a:rPr lang="ja-JP" altLang="en-US" sz="2400" b="1" dirty="0">
-                <a:solidFill>
-                  <a:srgbClr val="C00000"/>
-                </a:solidFill>
-                <a:latin typeface="メイリオ" pitchFamily="34" charset="0"/>
-                <a:ea typeface="メイリオ" pitchFamily="34" charset="-122"/>
-                <a:cs typeface="メイリオ" pitchFamily="34" charset="-120"/>
-              </a:rPr>
-              <a:t>緊急手術は 15%</a:t>
-            </a:r>
-            <a:endParaRPr lang="ja-JP" sz="2400" dirty="0"/>
-          </a:p>
-          <a:p>
-            <a:pPr algn="l" marL="355600" indent="-355600">
-              <a:spcAft>
-                <a:spcPts val="1200"/>
-              </a:spcAft>
-              <a:buSzPct val="100000"/>
-              <a:buChar char="•"/>
-            </a:pPr>
-            <a:r>
-              <a:rPr lang="ja-JP" altLang="en-US" sz="2400" dirty="0">
-                <a:solidFill>
-                  <a:srgbClr val="262626"/>
-                </a:solidFill>
-                <a:latin typeface="メイリオ" pitchFamily="34" charset="0"/>
-                <a:ea typeface="メイリオ" pitchFamily="34" charset="-122"/>
-                <a:cs typeface="メイリオ" pitchFamily="34" charset="-120"/>
-              </a:rPr>
-              <a:t>合併症を増やす：右房圧上昇、6 分間歩行 399 m 未満、昇圧薬、緊急</a:t>
-            </a:r>
-            <a:endParaRPr lang="ja-JP" sz="2400" dirty="0"/>
-          </a:p>
-          <a:p>
-            <a:pPr algn="l" marL="355600" indent="-355600">
-              <a:spcAft>
-                <a:spcPts val="1200"/>
-              </a:spcAft>
-              <a:buSzPct val="100000"/>
-              <a:buChar char="•"/>
-            </a:pPr>
-            <a:r>
-              <a:rPr lang="ja-JP" altLang="en-US" sz="2400" dirty="0">
-                <a:solidFill>
-                  <a:srgbClr val="262626"/>
-                </a:solidFill>
-                <a:latin typeface="メイリオ" pitchFamily="34" charset="0"/>
-                <a:ea typeface="メイリオ" pitchFamily="34" charset="-122"/>
-                <a:cs typeface="メイリオ" pitchFamily="34" charset="-120"/>
-              </a:rPr>
-              <a:t>肺高血圧の治療薬は続ける（I）。心エコー・右心カテで層別化</a:t>
-            </a:r>
-            <a:endParaRPr lang="ja-JP" sz="2400" dirty="0"/>
-          </a:p>
-          <a:p>
-            <a:pPr algn="l" marL="355600" indent="-355600">
-              <a:spcAft>
-                <a:spcPts val="1200"/>
-              </a:spcAft>
-              <a:buSzPct val="100000"/>
-              <a:buChar char="•"/>
-            </a:pPr>
-            <a:r>
-              <a:rPr lang="ja-JP" altLang="en-US" sz="2400" b="1" dirty="0">
-                <a:solidFill>
-                  <a:srgbClr val="D55E00"/>
-                </a:solidFill>
-                <a:latin typeface="メイリオ" pitchFamily="34" charset="0"/>
-                <a:ea typeface="メイリオ" pitchFamily="34" charset="-122"/>
-                <a:cs typeface="メイリオ" pitchFamily="34" charset="-120"/>
-              </a:rPr>
-              <a:t>避ける：</a:t>
-            </a:r>
-            <a:r>
-              <a:rPr lang="ja-JP" altLang="en-US" sz="2400" dirty="0">
-                <a:solidFill>
-                  <a:srgbClr val="262626"/>
-                </a:solidFill>
-                <a:latin typeface="メイリオ" pitchFamily="34" charset="0"/>
-                <a:ea typeface="メイリオ" pitchFamily="34" charset="-122"/>
-                <a:cs typeface="メイリオ" pitchFamily="34" charset="-120"/>
-              </a:rPr>
-              <a:t>低酸素、高 CO2、アシドーシス、低体温、低血圧</a:t>
-            </a:r>
-            <a:endParaRPr lang="ja-JP" sz="2400" dirty="0"/>
-          </a:p>
-        </p:txBody>
-      </p:sp>
-      <p:sp>
-        <p:nvSpPr>
-          <p:cNvPr id="12" name="Shape 10"/>
+          <p:cNvPr id="12" name="Shape 9"/>
           <p:cNvSpPr/>
           <p:nvPr/>
         </p:nvSpPr>
         <p:spPr>
           <a:xfrm>
-            <a:off x="502920" y="4946904"/>
+            <a:off x="502920" y="4997196"/>
             <a:ext cx="11183112" cy="914400"/>
           </a:xfrm>
           <a:prstGeom prst="roundRect">
@@ -11397,7 +11750,7 @@
       </p:sp>
       <p:graphicFrame>
         <p:nvGraphicFramePr>
-          <p:cNvPr id="13" name="Table 0"/>
+          <p:cNvPr id="13" name="Table 1"/>
           <p:cNvGraphicFramePr>
             <a:graphicFrameLocks noGrp="1"/>
           </p:cNvGraphicFramePr>
@@ -11410,7 +11763,7 @@
           </p:nvPr>
         </p:nvGraphicFramePr>
         <p:xfrm>
-          <a:off x="594360" y="5038344"/>
+          <a:off x="594360" y="5088636"/>
           <a:ext cx="11000232" cy="914400"/>
         </p:xfrm>
         <a:graphic>
@@ -11927,7 +12280,7 @@
                 <a:ea typeface="メイリオ" pitchFamily="34" charset="-122"/>
                 <a:cs typeface="メイリオ" pitchFamily="34" charset="-120"/>
               </a:rPr>
-              <a:t>Thompson A, et al. Circulation 2024;150:e351-e442/日本循環器学会 2022 年改訂版</a:t>
+              <a:t>Thompson A, et al. Circulation 2024;150:e351-e442（2024 AHA/ACC）</a:t>
             </a:r>
             <a:endParaRPr lang="ja-JP" sz="1600" dirty="0"/>
           </a:p>
@@ -11944,7 +12297,7 @@
                 <a:ea typeface="メイリオ" pitchFamily="34" charset="-122"/>
                 <a:cs typeface="メイリオ" pitchFamily="34" charset="-120"/>
               </a:rPr>
-              <a:t>非心臓手術における合併心疾患ガイドライン/Hawn MT, et al. JAMA 2013;310:1462-1472</a:t>
+              <a:t>JCS 2022 非心臓手術ガイドライン / Hawn MT, et al. JAMA 2013;310:1462-1472</a:t>
             </a:r>
             <a:endParaRPr lang="ja-JP" sz="1600" dirty="0"/>
           </a:p>

</xml_diff>